<commit_message>
Update premium presentation deck
</commit_message>
<xml_diff>
--- a/final_submission/confidence_triggered_swarm_premium.pptx
+++ b/final_submission/confidence_triggered_swarm_premium.pptx
@@ -16236,7 +16236,7 @@
         </p:nvSpPr>
         <p:spPr>
           <a:xfrm>
-            <a:off x="5230368" y="2276856"/>
+            <a:off x="5230368" y="2200078"/>
             <a:ext cx="3383280" cy="502920"/>
           </a:xfrm>
           <a:prstGeom prst="rect">
@@ -16272,7 +16272,7 @@
         </p:nvSpPr>
         <p:spPr>
           <a:xfrm>
-            <a:off x="4892040" y="2907792"/>
+            <a:off x="4892040" y="2719394"/>
             <a:ext cx="256032" cy="256032"/>
           </a:xfrm>
           <a:prstGeom prst="roundRect">
@@ -16306,7 +16306,7 @@
         </p:nvSpPr>
         <p:spPr>
           <a:xfrm>
-            <a:off x="4892040" y="2907792"/>
+            <a:off x="4892040" y="2719394"/>
             <a:ext cx="256032" cy="256032"/>
           </a:xfrm>
           <a:prstGeom prst="rect">
@@ -16342,7 +16342,7 @@
         </p:nvSpPr>
         <p:spPr>
           <a:xfrm>
-            <a:off x="5230368" y="2907792"/>
+            <a:off x="5230368" y="2719394"/>
             <a:ext cx="3383280" cy="256032"/>
           </a:xfrm>
           <a:prstGeom prst="rect">
@@ -16378,7 +16378,7 @@
         </p:nvSpPr>
         <p:spPr>
           <a:xfrm>
-            <a:off x="5230368" y="3191256"/>
+            <a:off x="5230368" y="2930652"/>
             <a:ext cx="3383280" cy="502920"/>
           </a:xfrm>
           <a:prstGeom prst="rect">
@@ -16414,7 +16414,7 @@
         </p:nvSpPr>
         <p:spPr>
           <a:xfrm>
-            <a:off x="4892040" y="3822192"/>
+            <a:off x="4892040" y="3574043"/>
             <a:ext cx="256032" cy="256032"/>
           </a:xfrm>
           <a:prstGeom prst="roundRect">
@@ -16448,7 +16448,7 @@
         </p:nvSpPr>
         <p:spPr>
           <a:xfrm>
-            <a:off x="4892040" y="3822192"/>
+            <a:off x="4892040" y="3574043"/>
             <a:ext cx="256032" cy="256032"/>
           </a:xfrm>
           <a:prstGeom prst="rect">
@@ -16484,7 +16484,7 @@
         </p:nvSpPr>
         <p:spPr>
           <a:xfrm>
-            <a:off x="5230368" y="3822192"/>
+            <a:off x="5230368" y="3574043"/>
             <a:ext cx="3383280" cy="256032"/>
           </a:xfrm>
           <a:prstGeom prst="rect">
@@ -16520,8 +16520,8 @@
         </p:nvSpPr>
         <p:spPr>
           <a:xfrm>
-            <a:off x="5230368" y="4105656"/>
-            <a:ext cx="3383280" cy="502920"/>
+            <a:off x="5230368" y="3903542"/>
+            <a:ext cx="3383280" cy="256032"/>
           </a:xfrm>
           <a:prstGeom prst="rect">
             <a:avLst/>
@@ -16659,8 +16659,8 @@
         </p:nvSpPr>
         <p:spPr>
           <a:xfrm>
-            <a:off x="384048" y="256032"/>
-            <a:ext cx="1422806" cy="201168"/>
+            <a:off x="384047" y="256032"/>
+            <a:ext cx="1499931" cy="201168"/>
           </a:xfrm>
           <a:prstGeom prst="roundRect">
             <a:avLst>
@@ -16693,8 +16693,8 @@
         </p:nvSpPr>
         <p:spPr>
           <a:xfrm>
-            <a:off x="384048" y="256032"/>
-            <a:ext cx="1422806" cy="201168"/>
+            <a:off x="427181" y="256032"/>
+            <a:ext cx="1413662" cy="201168"/>
           </a:xfrm>
           <a:prstGeom prst="rect">
             <a:avLst/>
@@ -17181,7 +17181,7 @@
         </p:nvSpPr>
         <p:spPr>
           <a:xfrm>
-            <a:off x="384048" y="2633472"/>
+            <a:off x="393192" y="2546604"/>
             <a:ext cx="4846320" cy="237744"/>
           </a:xfrm>
           <a:prstGeom prst="rect">
@@ -17218,13 +17218,13 @@
           <p:nvPr>
             <p:extLst>
               <p:ext uri="{D42A27DB-BD31-4B8C-83A1-F6EECF244321}">
-                <p14:modId xmlns:p14="http://schemas.microsoft.com/office/powerpoint/2010/main" val="1579011935"/>
+                <p14:modId xmlns:p14="http://schemas.microsoft.com/office/powerpoint/2010/main" val="3731158617"/>
               </p:ext>
             </p:extLst>
           </p:nvPr>
         </p:nvGraphicFramePr>
         <p:xfrm>
-          <a:off x="384048" y="2907792"/>
+          <a:off x="384048" y="2825496"/>
           <a:ext cx="4846320" cy="1920240"/>
         </p:xfrm>
         <a:graphic>
@@ -19334,84 +19334,6 @@
           </a:p>
         </p:txBody>
       </p:sp>
-      <p:sp>
-        <p:nvSpPr>
-          <p:cNvPr id="32" name="Shape 29"/>
-          <p:cNvSpPr/>
-          <p:nvPr/>
-        </p:nvSpPr>
-        <p:spPr>
-          <a:xfrm>
-            <a:off x="384048" y="4773168"/>
-            <a:ext cx="8394192" cy="201168"/>
-          </a:xfrm>
-          <a:prstGeom prst="roundRect">
-            <a:avLst>
-              <a:gd name="adj" fmla="val 22727"/>
-            </a:avLst>
-          </a:prstGeom>
-          <a:solidFill>
-            <a:srgbClr val="120D00"/>
-          </a:solidFill>
-          <a:ln w="6350">
-            <a:solidFill>
-              <a:srgbClr val="C9922A"/>
-            </a:solidFill>
-            <a:prstDash val="solid"/>
-          </a:ln>
-        </p:spPr>
-        <p:txBody>
-          <a:bodyPr/>
-          <a:lstStyle/>
-          <a:p>
-            <a:endParaRPr lang="en-US"/>
-          </a:p>
-        </p:txBody>
-      </p:sp>
-      <p:sp>
-        <p:nvSpPr>
-          <p:cNvPr id="33" name="Text 30"/>
-          <p:cNvSpPr/>
-          <p:nvPr/>
-        </p:nvSpPr>
-        <p:spPr>
-          <a:xfrm>
-            <a:off x="502920" y="4782312"/>
-            <a:ext cx="8229600" cy="182880"/>
-          </a:xfrm>
-          <a:prstGeom prst="rect">
-            <a:avLst/>
-          </a:prstGeom>
-          <a:noFill/>
-          <a:ln/>
-        </p:spPr>
-        <p:txBody>
-          <a:bodyPr wrap="square" lIns="0" tIns="0" rIns="0" bIns="0" rtlCol="0" anchor="ctr"/>
-          <a:lstStyle/>
-          <a:p>
-            <a:pPr marL="0" indent="0">
-              <a:buNone/>
-            </a:pPr>
-            <a:r>
-              <a:rPr lang="en-US" sz="880" b="1" dirty="0">
-                <a:solidFill>
-                  <a:srgbClr val="C9922A"/>
-                </a:solidFill>
-              </a:rPr>
-              <a:t>Note  </a:t>
-            </a:r>
-            <a:r>
-              <a:rPr lang="en-US" sz="880" dirty="0">
-                <a:solidFill>
-                  <a:srgbClr val="808080"/>
-                </a:solidFill>
-              </a:rPr>
-              <a:t>Baseline trained on clean episodes only — surprises injected only at evaluation time.</a:t>
-            </a:r>
-            <a:endParaRPr lang="en-US" sz="880" dirty="0"/>
-          </a:p>
-        </p:txBody>
-      </p:sp>
     </p:spTree>
   </p:cSld>
   <p:clrMapOvr>
@@ -22019,84 +21941,6 @@
           </a:prstGeom>
         </p:spPr>
       </p:pic>
-      <p:sp>
-        <p:nvSpPr>
-          <p:cNvPr id="41" name="Shape 38"/>
-          <p:cNvSpPr/>
-          <p:nvPr/>
-        </p:nvSpPr>
-        <p:spPr>
-          <a:xfrm>
-            <a:off x="384048" y="4773168"/>
-            <a:ext cx="8394192" cy="201168"/>
-          </a:xfrm>
-          <a:prstGeom prst="roundRect">
-            <a:avLst>
-              <a:gd name="adj" fmla="val 22727"/>
-            </a:avLst>
-          </a:prstGeom>
-          <a:solidFill>
-            <a:srgbClr val="120D00"/>
-          </a:solidFill>
-          <a:ln w="6350">
-            <a:solidFill>
-              <a:srgbClr val="C9922A"/>
-            </a:solidFill>
-            <a:prstDash val="solid"/>
-          </a:ln>
-        </p:spPr>
-        <p:txBody>
-          <a:bodyPr/>
-          <a:lstStyle/>
-          <a:p>
-            <a:endParaRPr lang="en-US"/>
-          </a:p>
-        </p:txBody>
-      </p:sp>
-      <p:sp>
-        <p:nvSpPr>
-          <p:cNvPr id="42" name="Text 39"/>
-          <p:cNvSpPr/>
-          <p:nvPr/>
-        </p:nvSpPr>
-        <p:spPr>
-          <a:xfrm>
-            <a:off x="502920" y="4782312"/>
-            <a:ext cx="8229600" cy="182880"/>
-          </a:xfrm>
-          <a:prstGeom prst="rect">
-            <a:avLst/>
-          </a:prstGeom>
-          <a:noFill/>
-          <a:ln/>
-        </p:spPr>
-        <p:txBody>
-          <a:bodyPr wrap="square" lIns="0" tIns="0" rIns="0" bIns="0" rtlCol="0" anchor="ctr"/>
-          <a:lstStyle/>
-          <a:p>
-            <a:pPr marL="0" indent="0">
-              <a:buNone/>
-            </a:pPr>
-            <a:r>
-              <a:rPr lang="en-US" sz="880" b="1" dirty="0">
-                <a:solidFill>
-                  <a:srgbClr val="C9922A"/>
-                </a:solidFill>
-              </a:rPr>
-              <a:t>Honest note  </a:t>
-            </a:r>
-            <a:r>
-              <a:rPr lang="en-US" sz="880" dirty="0">
-                <a:solidFill>
-                  <a:srgbClr val="808080"/>
-                </a:solidFill>
-              </a:rPr>
-              <a:t>Single seed (seed = 42). Moderate severity regresses. Results are directional, not statistically definitive.</a:t>
-            </a:r>
-            <a:endParaRPr lang="en-US" sz="880" dirty="0"/>
-          </a:p>
-        </p:txBody>
-      </p:sp>
     </p:spTree>
   </p:cSld>
   <p:clrMapOvr>
@@ -22132,6 +21976,46 @@
       </p:grpSpPr>
       <p:sp>
         <p:nvSpPr>
+          <p:cNvPr id="2" name="Shape 22">
+            <a:extLst>
+              <a:ext uri="{FF2B5EF4-FFF2-40B4-BE49-F238E27FC236}">
+                <a16:creationId xmlns:a16="http://schemas.microsoft.com/office/drawing/2014/main" id="{B7021F0D-8DA6-EFAA-9F3A-37E53E768655}"/>
+              </a:ext>
+            </a:extLst>
+          </p:cNvPr>
+          <p:cNvSpPr/>
+          <p:nvPr/>
+        </p:nvSpPr>
+        <p:spPr>
+          <a:xfrm>
+            <a:off x="384048" y="4206240"/>
+            <a:ext cx="5257800" cy="420624"/>
+          </a:xfrm>
+          <a:prstGeom prst="roundRect">
+            <a:avLst>
+              <a:gd name="adj" fmla="val 21739"/>
+            </a:avLst>
+          </a:prstGeom>
+          <a:solidFill>
+            <a:srgbClr val="120D00"/>
+          </a:solidFill>
+          <a:ln w="8890">
+            <a:solidFill>
+              <a:srgbClr val="C9922A"/>
+            </a:solidFill>
+            <a:prstDash val="solid"/>
+          </a:ln>
+        </p:spPr>
+        <p:txBody>
+          <a:bodyPr/>
+          <a:lstStyle/>
+          <a:p>
+            <a:endParaRPr lang="en-US"/>
+          </a:p>
+        </p:txBody>
+      </p:sp>
+      <p:sp>
+        <p:nvSpPr>
           <p:cNvPr id="3" name="Shape 1"/>
           <p:cNvSpPr/>
           <p:nvPr/>
@@ -22344,7 +22228,7 @@
         </p:nvSpPr>
         <p:spPr>
           <a:xfrm>
-            <a:off x="5833872" y="1371600"/>
+            <a:off x="5833872" y="1453423"/>
             <a:ext cx="2971800" cy="1234440"/>
           </a:xfrm>
           <a:prstGeom prst="roundRect">
@@ -22385,7 +22269,7 @@
         </p:nvSpPr>
         <p:spPr>
           <a:xfrm>
-            <a:off x="5998464" y="1463040"/>
+            <a:off x="5998464" y="1544863"/>
             <a:ext cx="2651760" cy="201168"/>
           </a:xfrm>
           <a:prstGeom prst="rect">
@@ -22421,7 +22305,7 @@
         </p:nvSpPr>
         <p:spPr>
           <a:xfrm>
-            <a:off x="5998464" y="1664208"/>
+            <a:off x="5998464" y="1746031"/>
             <a:ext cx="2651760" cy="512064"/>
           </a:xfrm>
           <a:prstGeom prst="rect">
@@ -22457,7 +22341,7 @@
         </p:nvSpPr>
         <p:spPr>
           <a:xfrm>
-            <a:off x="5998464" y="2212848"/>
+            <a:off x="5998464" y="2294671"/>
             <a:ext cx="2651760" cy="182880"/>
           </a:xfrm>
           <a:prstGeom prst="rect">
@@ -22493,7 +22377,7 @@
         </p:nvSpPr>
         <p:spPr>
           <a:xfrm>
-            <a:off x="5833872" y="2761488"/>
+            <a:off x="5833872" y="2843311"/>
             <a:ext cx="2971800" cy="1234440"/>
           </a:xfrm>
           <a:prstGeom prst="roundRect">
@@ -22534,7 +22418,7 @@
         </p:nvSpPr>
         <p:spPr>
           <a:xfrm>
-            <a:off x="5998464" y="2852928"/>
+            <a:off x="5998464" y="2934751"/>
             <a:ext cx="2651760" cy="201168"/>
           </a:xfrm>
           <a:prstGeom prst="rect">
@@ -22570,7 +22454,7 @@
         </p:nvSpPr>
         <p:spPr>
           <a:xfrm>
-            <a:off x="5998464" y="3054096"/>
+            <a:off x="5998464" y="3135919"/>
             <a:ext cx="2651760" cy="512064"/>
           </a:xfrm>
           <a:prstGeom prst="rect">
@@ -22606,7 +22490,7 @@
         </p:nvSpPr>
         <p:spPr>
           <a:xfrm>
-            <a:off x="5998464" y="3602736"/>
+            <a:off x="5998464" y="3684559"/>
             <a:ext cx="2651760" cy="182880"/>
           </a:xfrm>
           <a:prstGeom prst="rect">
@@ -22642,7 +22526,7 @@
         </p:nvSpPr>
         <p:spPr>
           <a:xfrm>
-            <a:off x="5833872" y="4078224"/>
+            <a:off x="5833872" y="4160047"/>
             <a:ext cx="2971800" cy="402336"/>
           </a:xfrm>
           <a:prstGeom prst="roundRect">
@@ -22676,7 +22560,7 @@
         </p:nvSpPr>
         <p:spPr>
           <a:xfrm>
-            <a:off x="5833872" y="4078224"/>
+            <a:off x="5833872" y="4160047"/>
             <a:ext cx="2971800" cy="402336"/>
           </a:xfrm>
           <a:prstGeom prst="rect">
@@ -22712,8 +22596,8 @@
         </p:nvSpPr>
         <p:spPr>
           <a:xfrm>
-            <a:off x="384048" y="4206240"/>
-            <a:ext cx="5257800" cy="457200"/>
+            <a:off x="475488" y="4187952"/>
+            <a:ext cx="5074920" cy="457200"/>
           </a:xfrm>
           <a:prstGeom prst="rect">
             <a:avLst/>
@@ -22725,13 +22609,14 @@
           <a:bodyPr wrap="square" lIns="0" tIns="0" rIns="0" bIns="0" rtlCol="0" anchor="ctr"/>
           <a:lstStyle/>
           <a:p>
+            <a:pPr algn="ctr"/>
             <a:r>
               <a:rPr lang="en-US" sz="950" i="1" dirty="0">
                 <a:solidFill>
                   <a:srgbClr val="808080"/>
                 </a:solidFill>
               </a:rPr>
-              <a:t>With KL anchoring, clean replay, and EWC active, clean performance was retained even after adapting to the hardest surprise condition. Waypoints slightly lower — reported as retention, not improvement.</a:t>
+              <a:t>With KL anchoring, clean replay, and EWC active, clean performance was retained even after adapting to the hardest surprise condition</a:t>
             </a:r>
             <a:endParaRPr lang="en-US" sz="950" dirty="0"/>
           </a:p>

</xml_diff>